<commit_message>
adding interactive calendar with teacher profiles
</commit_message>
<xml_diff>
--- a/assets/downloads/Game_Production_Course_Structure.pptx
+++ b/assets/downloads/Game_Production_Course_Structure.pptx
@@ -604,7 +604,7 @@
           <a:p>
             <a:r>
               <a:rPr lang="en-US" dirty="0"/>
-              <a:t>Phase 04: Reflect — Peeling the onion. Course weeks 15–16 · calendar weeks 50–51  ·  and week 1 / 2027.</a:t>
+              <a:t>Phase 04: Reflect — Peeling the onion. Course weeks 15–17  ·  calendar weeks 50–51, continuing into week 01 / 2027.</a:t>
             </a:r>
             <a:endParaRPr lang="en-US" dirty="0"/>
           </a:p>
@@ -2968,7 +2968,7 @@
                 <a:ea typeface="Calibri" pitchFamily="34" charset="-122"/>
                 <a:cs typeface="Calibri" pitchFamily="34" charset="-120"/>
               </a:rPr>
-              <a:t>Course weeks 15–16 · calendar weeks 50–51  ·  and week 1 / 2027</a:t>
+              <a:t>Course weeks 15–17  ·  calendar weeks 50–51, continuing into week 01 / 2027</a:t>
             </a:r>
             <a:endParaRPr lang="en-US" sz="1300" dirty="0"/>
           </a:p>
@@ -3176,7 +3176,7 @@
                 <a:ea typeface="Calibri" pitchFamily="34" charset="-122"/>
                 <a:cs typeface="Calibri" pitchFamily="34" charset="-120"/>
               </a:rPr>
-              <a:t>cal. 50</a:t>
+              <a:t>week 50</a:t>
             </a:r>
             <a:endParaRPr lang="en-US" sz="2000" dirty="0"/>
           </a:p>
@@ -3449,7 +3449,7 @@
                 <a:ea typeface="Calibri" pitchFamily="34" charset="-122"/>
                 <a:cs typeface="Calibri" pitchFamily="34" charset="-120"/>
               </a:rPr>
-              <a:t>cal. 51</a:t>
+              <a:t>week 51</a:t>
             </a:r>
             <a:endParaRPr lang="en-US" sz="2000" dirty="0"/>
           </a:p>
@@ -3702,7 +3702,7 @@
                 <a:ea typeface="Calibri" pitchFamily="34" charset="-122"/>
                 <a:cs typeface="Calibri" pitchFamily="34" charset="-120"/>
               </a:rPr>
-              <a:t>1 ’27</a:t>
+              <a:t>17</a:t>
             </a:r>
             <a:endParaRPr lang="en-US" sz="2000" dirty="0"/>
           </a:p>
@@ -3722,7 +3722,7 @@
                 <a:ea typeface="Calibri" pitchFamily="34" charset="-122"/>
                 <a:cs typeface="Calibri" pitchFamily="34" charset="-120"/>
               </a:rPr>
-              <a:t>cal. 01</a:t>
+              <a:t>week 01/2027</a:t>
             </a:r>
             <a:endParaRPr lang="en-US" sz="2000" dirty="0"/>
           </a:p>
@@ -4426,7 +4426,7 @@
                 <a:ea typeface="Calibri" pitchFamily="34" charset="-122"/>
                 <a:cs typeface="Calibri" pitchFamily="34" charset="-120"/>
               </a:rPr>
-              <a:t>wk 36</a:t>
+              <a:t>week 36</a:t>
             </a:r>
             <a:endParaRPr lang="en-US" sz="950" dirty="0"/>
           </a:p>
@@ -4446,7 +4446,7 @@
                 <a:ea typeface="Calibri" pitchFamily="34" charset="-122"/>
                 <a:cs typeface="Calibri" pitchFamily="34" charset="-120"/>
               </a:rPr>
-              <a:t>course wk 1</a:t>
+              <a:t>course 1</a:t>
             </a:r>
             <a:endParaRPr lang="en-US" sz="950" dirty="0"/>
           </a:p>
@@ -4966,7 +4966,7 @@
                 <a:ea typeface="Calibri" pitchFamily="34" charset="-122"/>
                 <a:cs typeface="Calibri" pitchFamily="34" charset="-120"/>
               </a:rPr>
-              <a:t>wk 37</a:t>
+              <a:t>week 37</a:t>
             </a:r>
             <a:endParaRPr lang="en-US" sz="950" dirty="0"/>
           </a:p>
@@ -4986,7 +4986,7 @@
                 <a:ea typeface="Calibri" pitchFamily="34" charset="-122"/>
                 <a:cs typeface="Calibri" pitchFamily="34" charset="-120"/>
               </a:rPr>
-              <a:t>course wk 2</a:t>
+              <a:t>course 2</a:t>
             </a:r>
             <a:endParaRPr lang="en-US" sz="950" dirty="0"/>
           </a:p>
@@ -5574,7 +5574,7 @@
                 <a:ea typeface="Calibri" pitchFamily="34" charset="-122"/>
                 <a:cs typeface="Calibri" pitchFamily="34" charset="-120"/>
               </a:rPr>
-              <a:t>wk 38</a:t>
+              <a:t>week 38</a:t>
             </a:r>
             <a:endParaRPr lang="en-US" sz="950" dirty="0"/>
           </a:p>
@@ -5594,7 +5594,7 @@
                 <a:ea typeface="Calibri" pitchFamily="34" charset="-122"/>
                 <a:cs typeface="Calibri" pitchFamily="34" charset="-120"/>
               </a:rPr>
-              <a:t>course wk 3</a:t>
+              <a:t>course 3</a:t>
             </a:r>
             <a:endParaRPr lang="en-US" sz="950" dirty="0"/>
           </a:p>
@@ -6182,7 +6182,7 @@
                 <a:ea typeface="Calibri" pitchFamily="34" charset="-122"/>
                 <a:cs typeface="Calibri" pitchFamily="34" charset="-120"/>
               </a:rPr>
-              <a:t>wk 39</a:t>
+              <a:t>week 39</a:t>
             </a:r>
             <a:endParaRPr lang="en-US" sz="950" dirty="0"/>
           </a:p>
@@ -6202,7 +6202,7 @@
                 <a:ea typeface="Calibri" pitchFamily="34" charset="-122"/>
                 <a:cs typeface="Calibri" pitchFamily="34" charset="-120"/>
               </a:rPr>
-              <a:t>course wk 4</a:t>
+              <a:t>course 4</a:t>
             </a:r>
             <a:endParaRPr lang="en-US" sz="950" dirty="0"/>
           </a:p>
@@ -6790,7 +6790,7 @@
                 <a:ea typeface="Calibri" pitchFamily="34" charset="-122"/>
                 <a:cs typeface="Calibri" pitchFamily="34" charset="-120"/>
               </a:rPr>
-              <a:t>wk 40</a:t>
+              <a:t>week 40</a:t>
             </a:r>
             <a:endParaRPr lang="en-US" sz="950" dirty="0"/>
           </a:p>
@@ -6810,7 +6810,7 @@
                 <a:ea typeface="Calibri" pitchFamily="34" charset="-122"/>
                 <a:cs typeface="Calibri" pitchFamily="34" charset="-120"/>
               </a:rPr>
-              <a:t>course wk 5</a:t>
+              <a:t>course 5</a:t>
             </a:r>
             <a:endParaRPr lang="en-US" sz="950" dirty="0"/>
           </a:p>
@@ -7438,7 +7438,7 @@
                 <a:ea typeface="Calibri" pitchFamily="34" charset="-122"/>
                 <a:cs typeface="Calibri" pitchFamily="34" charset="-120"/>
               </a:rPr>
-              <a:t>wk 40</a:t>
+              <a:t>week 40</a:t>
             </a:r>
             <a:endParaRPr lang="en-US" sz="950" dirty="0"/>
           </a:p>
@@ -7761,7 +7761,7 @@
                 <a:ea typeface="Calibri" pitchFamily="34" charset="-122"/>
                 <a:cs typeface="Calibri" pitchFamily="34" charset="-120"/>
               </a:rPr>
-              <a:t>wk 41</a:t>
+              <a:t>week 41</a:t>
             </a:r>
             <a:endParaRPr lang="en-US" sz="950" dirty="0"/>
           </a:p>
@@ -7781,7 +7781,7 @@
                 <a:ea typeface="Calibri" pitchFamily="34" charset="-122"/>
                 <a:cs typeface="Calibri" pitchFamily="34" charset="-120"/>
               </a:rPr>
-              <a:t>course wk 6</a:t>
+              <a:t>course 6</a:t>
             </a:r>
             <a:endParaRPr lang="en-US" sz="950" dirty="0"/>
           </a:p>
@@ -8369,7 +8369,7 @@
                 <a:ea typeface="Calibri" pitchFamily="34" charset="-122"/>
                 <a:cs typeface="Calibri" pitchFamily="34" charset="-120"/>
               </a:rPr>
-              <a:t>wk 42</a:t>
+              <a:t>week 42</a:t>
             </a:r>
             <a:endParaRPr lang="en-US" sz="950" dirty="0"/>
           </a:p>
@@ -8389,7 +8389,7 @@
                 <a:ea typeface="Calibri" pitchFamily="34" charset="-122"/>
                 <a:cs typeface="Calibri" pitchFamily="34" charset="-120"/>
               </a:rPr>
-              <a:t>course wk 7</a:t>
+              <a:t>course 7</a:t>
             </a:r>
             <a:endParaRPr lang="en-US" sz="950" dirty="0"/>
           </a:p>
@@ -8977,7 +8977,7 @@
                 <a:ea typeface="Calibri" pitchFamily="34" charset="-122"/>
                 <a:cs typeface="Calibri" pitchFamily="34" charset="-120"/>
               </a:rPr>
-              <a:t>wk 43</a:t>
+              <a:t>week 43</a:t>
             </a:r>
             <a:endParaRPr lang="en-US" sz="950" dirty="0"/>
           </a:p>
@@ -8997,7 +8997,7 @@
                 <a:ea typeface="Calibri" pitchFamily="34" charset="-122"/>
                 <a:cs typeface="Calibri" pitchFamily="34" charset="-120"/>
               </a:rPr>
-              <a:t>course wk 8</a:t>
+              <a:t>course 8</a:t>
             </a:r>
             <a:endParaRPr lang="en-US" sz="950" dirty="0"/>
           </a:p>
@@ -9585,7 +9585,7 @@
                 <a:ea typeface="Calibri" pitchFamily="34" charset="-122"/>
                 <a:cs typeface="Calibri" pitchFamily="34" charset="-120"/>
               </a:rPr>
-              <a:t>wk 44</a:t>
+              <a:t>week 44</a:t>
             </a:r>
             <a:endParaRPr lang="en-US" sz="950" dirty="0"/>
           </a:p>
@@ -9605,7 +9605,7 @@
                 <a:ea typeface="Calibri" pitchFamily="34" charset="-122"/>
                 <a:cs typeface="Calibri" pitchFamily="34" charset="-120"/>
               </a:rPr>
-              <a:t>course wk 9</a:t>
+              <a:t>course 9</a:t>
             </a:r>
             <a:endParaRPr lang="en-US" sz="950" dirty="0"/>
           </a:p>
@@ -10730,7 +10730,7 @@
                 <a:ea typeface="Calibri" pitchFamily="34" charset="-122"/>
                 <a:cs typeface="Calibri" pitchFamily="34" charset="-120"/>
               </a:rPr>
-              <a:t>wk 44</a:t>
+              <a:t>week 44</a:t>
             </a:r>
             <a:endParaRPr lang="en-US" sz="950" dirty="0"/>
           </a:p>
@@ -10849,7 +10849,7 @@
                 <a:ea typeface="Calibri" pitchFamily="34" charset="-122"/>
                 <a:cs typeface="Calibri" pitchFamily="34" charset="-120"/>
               </a:rPr>
-              <a:t>wk 45</a:t>
+              <a:t>week 45</a:t>
             </a:r>
             <a:endParaRPr lang="en-US" sz="950" dirty="0"/>
           </a:p>
@@ -10869,7 +10869,7 @@
                 <a:ea typeface="Calibri" pitchFamily="34" charset="-122"/>
                 <a:cs typeface="Calibri" pitchFamily="34" charset="-120"/>
               </a:rPr>
-              <a:t>course wk 10</a:t>
+              <a:t>course 10</a:t>
             </a:r>
             <a:endParaRPr lang="en-US" sz="950" dirty="0"/>
           </a:p>
@@ -11457,7 +11457,7 @@
                 <a:ea typeface="Calibri" pitchFamily="34" charset="-122"/>
                 <a:cs typeface="Calibri" pitchFamily="34" charset="-120"/>
               </a:rPr>
-              <a:t>wk 46</a:t>
+              <a:t>week 46</a:t>
             </a:r>
             <a:endParaRPr lang="en-US" sz="950" dirty="0"/>
           </a:p>
@@ -11477,7 +11477,7 @@
                 <a:ea typeface="Calibri" pitchFamily="34" charset="-122"/>
                 <a:cs typeface="Calibri" pitchFamily="34" charset="-120"/>
               </a:rPr>
-              <a:t>course wk 11</a:t>
+              <a:t>course 11</a:t>
             </a:r>
             <a:endParaRPr lang="en-US" sz="950" dirty="0"/>
           </a:p>
@@ -12065,7 +12065,7 @@
                 <a:ea typeface="Calibri" pitchFamily="34" charset="-122"/>
                 <a:cs typeface="Calibri" pitchFamily="34" charset="-120"/>
               </a:rPr>
-              <a:t>wk 47</a:t>
+              <a:t>week 47</a:t>
             </a:r>
             <a:endParaRPr lang="en-US" sz="950" dirty="0"/>
           </a:p>
@@ -12085,7 +12085,7 @@
                 <a:ea typeface="Calibri" pitchFamily="34" charset="-122"/>
                 <a:cs typeface="Calibri" pitchFamily="34" charset="-120"/>
               </a:rPr>
-              <a:t>course wk 12</a:t>
+              <a:t>course 12</a:t>
             </a:r>
             <a:endParaRPr lang="en-US" sz="950" dirty="0"/>
           </a:p>
@@ -12673,7 +12673,7 @@
                 <a:ea typeface="Calibri" pitchFamily="34" charset="-122"/>
                 <a:cs typeface="Calibri" pitchFamily="34" charset="-120"/>
               </a:rPr>
-              <a:t>wk 48</a:t>
+              <a:t>week 48</a:t>
             </a:r>
             <a:endParaRPr lang="en-US" sz="950" dirty="0"/>
           </a:p>
@@ -12693,7 +12693,7 @@
                 <a:ea typeface="Calibri" pitchFamily="34" charset="-122"/>
                 <a:cs typeface="Calibri" pitchFamily="34" charset="-120"/>
               </a:rPr>
-              <a:t>course wk 13</a:t>
+              <a:t>course 13</a:t>
             </a:r>
             <a:endParaRPr lang="en-US" sz="950" dirty="0"/>
           </a:p>
@@ -13281,7 +13281,7 @@
                 <a:ea typeface="Calibri" pitchFamily="34" charset="-122"/>
                 <a:cs typeface="Calibri" pitchFamily="34" charset="-120"/>
               </a:rPr>
-              <a:t>wk 49</a:t>
+              <a:t>week 49</a:t>
             </a:r>
             <a:endParaRPr lang="en-US" sz="950" dirty="0"/>
           </a:p>
@@ -13712,7 +13712,7 @@
                 <a:ea typeface="Calibri" pitchFamily="34" charset="-122"/>
                 <a:cs typeface="Calibri" pitchFamily="34" charset="-120"/>
               </a:rPr>
-              <a:t>wk 49</a:t>
+              <a:t>week 49</a:t>
             </a:r>
             <a:endParaRPr lang="en-US" sz="950" dirty="0"/>
           </a:p>
@@ -14252,7 +14252,7 @@
                 <a:ea typeface="Calibri" pitchFamily="34" charset="-122"/>
                 <a:cs typeface="Calibri" pitchFamily="34" charset="-120"/>
               </a:rPr>
-              <a:t>wk 50</a:t>
+              <a:t>week 50</a:t>
             </a:r>
             <a:endParaRPr lang="en-US" sz="950" dirty="0"/>
           </a:p>
@@ -14272,7 +14272,7 @@
                 <a:ea typeface="Calibri" pitchFamily="34" charset="-122"/>
                 <a:cs typeface="Calibri" pitchFamily="34" charset="-120"/>
               </a:rPr>
-              <a:t>course wk 15</a:t>
+              <a:t>course 15</a:t>
             </a:r>
             <a:endParaRPr lang="en-US" sz="950" dirty="0"/>
           </a:p>
@@ -14860,7 +14860,7 @@
                 <a:ea typeface="Calibri" pitchFamily="34" charset="-122"/>
                 <a:cs typeface="Calibri" pitchFamily="34" charset="-120"/>
               </a:rPr>
-              <a:t>wk 51</a:t>
+              <a:t>week 51</a:t>
             </a:r>
             <a:endParaRPr lang="en-US" sz="950" dirty="0"/>
           </a:p>
@@ -14880,7 +14880,7 @@
                 <a:ea typeface="Calibri" pitchFamily="34" charset="-122"/>
                 <a:cs typeface="Calibri" pitchFamily="34" charset="-120"/>
               </a:rPr>
-              <a:t>course wk 16</a:t>
+              <a:t>course 16</a:t>
             </a:r>
             <a:endParaRPr lang="en-US" sz="950" dirty="0"/>
           </a:p>
@@ -15468,7 +15468,7 @@
                 <a:ea typeface="Calibri" pitchFamily="34" charset="-122"/>
                 <a:cs typeface="Calibri" pitchFamily="34" charset="-120"/>
               </a:rPr>
-              <a:t>wk 52</a:t>
+              <a:t>week 52</a:t>
             </a:r>
             <a:endParaRPr lang="en-US" sz="950" dirty="0"/>
           </a:p>
@@ -15957,7 +15957,7 @@
                 <a:ea typeface="Calibri" pitchFamily="34" charset="-122"/>
                 <a:cs typeface="Calibri" pitchFamily="34" charset="-120"/>
               </a:rPr>
-              <a:t>wk 53</a:t>
+              <a:t>week 53</a:t>
             </a:r>
             <a:endParaRPr lang="en-US" sz="950" dirty="0"/>
           </a:p>
@@ -23552,7 +23552,7 @@
                 <a:ea typeface="Calibri" pitchFamily="34" charset="-122"/>
                 <a:cs typeface="Calibri" pitchFamily="34" charset="-120"/>
               </a:rPr>
-              <a:t>Course weeks 1–16 correspond to calendar weeks 36–51 of 2026, continuing into week 1 of 2027.</a:t>
+              <a:t>Course weeks 1–16 correspond to calendar weeks 36–51 of 2026; course week 17 is calendar week 01 of 2027.</a:t>
             </a:r>
             <a:endParaRPr lang="en-US" sz="1350" dirty="0"/>
           </a:p>
@@ -24979,7 +24979,7 @@
                 <a:ea typeface="Calibri" pitchFamily="34" charset="-122"/>
                 <a:cs typeface="Calibri" pitchFamily="34" charset="-120"/>
               </a:rPr>
-              <a:t>1 ’27</a:t>
+              <a:t>17</a:t>
             </a:r>
             <a:endParaRPr lang="en-US" sz="1150" dirty="0"/>
           </a:p>
@@ -26183,7 +26183,7 @@
                 <a:ea typeface="Calibri" pitchFamily="34" charset="-122"/>
                 <a:cs typeface="Calibri" pitchFamily="34" charset="-120"/>
               </a:rPr>
-              <a:t>cal. 36</a:t>
+              <a:t>week 36</a:t>
             </a:r>
             <a:endParaRPr lang="en-US" sz="2000" dirty="0"/>
           </a:p>
@@ -26456,7 +26456,7 @@
                 <a:ea typeface="Calibri" pitchFamily="34" charset="-122"/>
                 <a:cs typeface="Calibri" pitchFamily="34" charset="-120"/>
               </a:rPr>
-              <a:t>cal. 37</a:t>
+              <a:t>week 37</a:t>
             </a:r>
             <a:endParaRPr lang="en-US" sz="2000" dirty="0"/>
           </a:p>
@@ -26729,7 +26729,7 @@
                 <a:ea typeface="Calibri" pitchFamily="34" charset="-122"/>
                 <a:cs typeface="Calibri" pitchFamily="34" charset="-120"/>
               </a:rPr>
-              <a:t>cal. 38</a:t>
+              <a:t>week 38</a:t>
             </a:r>
             <a:endParaRPr lang="en-US" sz="2000" dirty="0"/>
           </a:p>
@@ -27002,7 +27002,7 @@
                 <a:ea typeface="Calibri" pitchFamily="34" charset="-122"/>
                 <a:cs typeface="Calibri" pitchFamily="34" charset="-120"/>
               </a:rPr>
-              <a:t>cal. 39</a:t>
+              <a:t>week 39</a:t>
             </a:r>
             <a:endParaRPr lang="en-US" sz="2000" dirty="0"/>
           </a:p>
@@ -27275,7 +27275,7 @@
                 <a:ea typeface="Calibri" pitchFamily="34" charset="-122"/>
                 <a:cs typeface="Calibri" pitchFamily="34" charset="-120"/>
               </a:rPr>
-              <a:t>cal. 40</a:t>
+              <a:t>week 40</a:t>
             </a:r>
             <a:endParaRPr lang="en-US" sz="2000" dirty="0"/>
           </a:p>
@@ -27836,7 +27836,7 @@
                 <a:ea typeface="Calibri" pitchFamily="34" charset="-122"/>
                 <a:cs typeface="Calibri" pitchFamily="34" charset="-120"/>
               </a:rPr>
-              <a:t>cal. 41</a:t>
+              <a:t>week 41</a:t>
             </a:r>
             <a:endParaRPr lang="en-US" sz="2000" dirty="0"/>
           </a:p>
@@ -28109,7 +28109,7 @@
                 <a:ea typeface="Calibri" pitchFamily="34" charset="-122"/>
                 <a:cs typeface="Calibri" pitchFamily="34" charset="-120"/>
               </a:rPr>
-              <a:t>cal. 42</a:t>
+              <a:t>week 42</a:t>
             </a:r>
             <a:endParaRPr lang="en-US" sz="2000" dirty="0"/>
           </a:p>
@@ -28382,7 +28382,7 @@
                 <a:ea typeface="Calibri" pitchFamily="34" charset="-122"/>
                 <a:cs typeface="Calibri" pitchFamily="34" charset="-120"/>
               </a:rPr>
-              <a:t>cal. 43</a:t>
+              <a:t>week 43</a:t>
             </a:r>
             <a:endParaRPr lang="en-US" sz="2000" dirty="0"/>
           </a:p>
@@ -28655,7 +28655,7 @@
                 <a:ea typeface="Calibri" pitchFamily="34" charset="-122"/>
                 <a:cs typeface="Calibri" pitchFamily="34" charset="-120"/>
               </a:rPr>
-              <a:t>cal. 44</a:t>
+              <a:t>week 44</a:t>
             </a:r>
             <a:endParaRPr lang="en-US" sz="2000" dirty="0"/>
           </a:p>
@@ -29216,7 +29216,7 @@
                 <a:ea typeface="Calibri" pitchFamily="34" charset="-122"/>
                 <a:cs typeface="Calibri" pitchFamily="34" charset="-120"/>
               </a:rPr>
-              <a:t>cal. 45</a:t>
+              <a:t>week 45</a:t>
             </a:r>
             <a:endParaRPr lang="en-US" sz="2000" dirty="0"/>
           </a:p>
@@ -29489,7 +29489,7 @@
                 <a:ea typeface="Calibri" pitchFamily="34" charset="-122"/>
                 <a:cs typeface="Calibri" pitchFamily="34" charset="-120"/>
               </a:rPr>
-              <a:t>cal. 46</a:t>
+              <a:t>week 46</a:t>
             </a:r>
             <a:endParaRPr lang="en-US" sz="2000" dirty="0"/>
           </a:p>
@@ -29762,7 +29762,7 @@
                 <a:ea typeface="Calibri" pitchFamily="34" charset="-122"/>
                 <a:cs typeface="Calibri" pitchFamily="34" charset="-120"/>
               </a:rPr>
-              <a:t>cal. 47</a:t>
+              <a:t>week 47</a:t>
             </a:r>
             <a:endParaRPr lang="en-US" sz="2000" dirty="0"/>
           </a:p>
@@ -30035,7 +30035,7 @@
                 <a:ea typeface="Calibri" pitchFamily="34" charset="-122"/>
                 <a:cs typeface="Calibri" pitchFamily="34" charset="-120"/>
               </a:rPr>
-              <a:t>cal. 48</a:t>
+              <a:t>week 48</a:t>
             </a:r>
             <a:endParaRPr lang="en-US" sz="2000" dirty="0"/>
           </a:p>
@@ -30281,7 +30281,7 @@
                 <a:ea typeface="Calibri" pitchFamily="34" charset="-122"/>
                 <a:cs typeface="Calibri" pitchFamily="34" charset="-120"/>
               </a:rPr>
-              <a:t>cal. 49 · EXAM</a:t>
+              <a:t>week 49 · EXAM</a:t>
             </a:r>
             <a:endParaRPr lang="en-US" sz="2000" dirty="0"/>
           </a:p>

</xml_diff>